<commit_message>
L17: bản tiếng Nhật của deck (17 trang, Moda), ghi chú người thuyết trình trong PPTX
- lessons/L17/L17-ja.pptx, slides.ja.json, deck.ja.json, hình tiếng Nhật
- scripts/deckgen/gen_ja.py: gen.py cho chữ Nhật (Moda chỉ ngắt dòng ở khoảng trắng)
- L17.pptx: thêm speaker notes vào file xuất (Moda không xuất notes)

Co-Authored-By: Claude Sonnet 5.5 <noreply@anthropic.com>
Claude-Session: https://claude.ai/code/session_01CcCX9nq9M1UJyHkJE2iNAA
</commit_message>
<xml_diff>
--- a/lessons/L17/L17.pptx
+++ b/lessons/L17/L17.pptx
@@ -536,10 +536,8 @@
           <a:lstStyle/>
           <a:p>
             <a:r>
-              <a:rPr lang="en-US" dirty="0"/>
-              <a:t/>
-            </a:r>
-            <a:endParaRPr lang="en-US" dirty="0"/>
+              <a:t>Mở bài: khi nóng lên, urea trong AdBlue biến thành gì và ở nhiệt độ nào cặn dễ bám nhất? Bài đọc từ biểu đồ gia nhiệt urea "Source number 3"; phần số liệu lấy từ hình, phần giải thích là kiến thức đối chiếu với nguồn ở slide cuối.</a:t>
+            </a:r>
           </a:p>
         </p:txBody>
       </p:sp>
@@ -624,10 +622,8 @@
           <a:lstStyle/>
           <a:p>
             <a:r>
-              <a:rPr lang="en-US" dirty="0"/>
-              <a:t/>
-            </a:r>
-            <a:endParaRPr lang="en-US" dirty="0"/>
+              <a:t>Ở 350°C chỉ còn cyanuric acid khoảng 2% và ammelide 5,5%. Ammelide là chất bền nhất: còn khoảng 1% ở 400°C và về 0 ở 450°C. Tổng chất rắn còn khoảng 2,5% ở 400°C và 1% ở 450°C. Một lưu ý nhỏ: tổng trong hình ở 400°C (khoảng 2,5%) cao hơn tổng bốn chất đọc được (khoảng 1%), chênh nằm trong sai số đọc hình. Ý nghĩa thực tế: ống xả nóng từ khoảng 400°C trở lên gần như tự sạch cặn.</a:t>
+            </a:r>
           </a:p>
         </p:txBody>
       </p:sp>
@@ -712,10 +708,8 @@
           <a:lstStyle/>
           <a:p>
             <a:r>
-              <a:rPr lang="en-US" dirty="0"/>
-              <a:t/>
-            </a:r>
-            <a:endParaRPr lang="en-US" dirty="0"/>
+              <a:t>Năm điểm ngoặt là xương sống của bài. Một: biuret lên rồi xuống, vì nguồn tạo ra nó là urea đang cạn và nó cũng tự phân hủy. Hai: cyanuric acid là nơi biuret và HNCO đổ vào nên tăng vọt giữa 190 và 225°C. Ba: ammelide lên chậm nhưng sống lâu nhất. Bốn: total recovery giảm liên tục, nghĩa là mỗi bước đều nhả khí. Năm: từ 400°C gần như sạch. Nhắc người nghe rằng các lý do là phần giải thích của bài, đối chiếu với tài liệu, còn hình chỉ cho số liệu.</a:t>
+            </a:r>
           </a:p>
         </p:txBody>
       </p:sp>
@@ -800,10 +794,8 @@
           <a:lstStyle/>
           <a:p>
             <a:r>
-              <a:rPr lang="en-US" dirty="0"/>
-              <a:t/>
-            </a:r>
-            <a:endParaRPr lang="en-US" dirty="0"/>
+              <a:t>Thang màu này là suy luận của bài từ hình, không phải ngưỡng hiệu chỉnh của hãng nào. Vùng đỏ 190–325°C nguy hiểm vì đó là nơi chất rắn nhiều nhất và bền nhất. Vì sao nhiệt độ thành ống thấp lại đáng lo? Giọt AdBlue chạm thành tạo màng chất lỏng; khi màng bay hơi nó hút nhiệt làm thành nguội thêm, nên có lúc khí xả nóng mà thành vẫn nằm trong vùng đỏ. Vì vậy cần nhìn nhiệt độ thành, không chỉ nhiệt độ khí.</a:t>
+            </a:r>
           </a:p>
         </p:txBody>
       </p:sp>
@@ -888,10 +880,8 @@
           <a:lstStyle/>
           <a:p>
             <a:r>
-              <a:rPr lang="en-US" dirty="0"/>
-              <a:t/>
-            </a:r>
-            <a:endParaRPr lang="en-US" dirty="0"/>
+              <a:t>Bốn gợi ý này là suy luận từ biểu đồ và hóa học, không phải thông số của một hãng. Một: đặt nhiệt độ tối thiểu bắt đầu dosing theo nhiệt độ thành, không chỉ khí. Hai: strategy phun giữ giọt nhỏ và tránh chạm thành lạnh, giảm lượng khi nhiệt độ thấp. Ba: thiết kế mixer giúp giọt bay hơi nhanh và hạn chế vùng đọng. Bốn: làm sạch bằng nhiệt, tức regeneration, đưa thành lên khoảng 400°C trở lên, vì ở đó biểu đồ cho thấy cặn gần như biến mất. Ngưỡng cụ thể phải do nhà sản xuất hiệu chỉnh.</a:t>
+            </a:r>
           </a:p>
         </p:txBody>
       </p:sp>
@@ -976,10 +966,8 @@
           <a:lstStyle/>
           <a:p>
             <a:r>
-              <a:rPr lang="en-US" dirty="0"/>
-              <a:t/>
-            </a:r>
-            <a:endParaRPr lang="en-US" dirty="0"/>
+              <a:t>Năm ý này đủ để người nghe kể lại câu chuyện. Một: urea nóng chảy rồi tách khí. Hai: biuret là trạm trung gian, lên đỉnh ở 190°C rồi hết. Ba: cyanuric acid là cặn chính, ammelide ít hơn nhưng bền hơn. Bốn: khối lượng chất rắn giảm dần vì chuyển thành khí. Năm: vùng nguy hiểm là 190–325°C, từ khoảng 400°C gần như sạch. Hỏi người nghe: trong xe của mình, vùng nào hay xảy ra nhất, và thành ống nóng lên chậm hơn khí bao lâu?</a:t>
+            </a:r>
           </a:p>
         </p:txBody>
       </p:sp>
@@ -1064,10 +1052,8 @@
           <a:lstStyle/>
           <a:p>
             <a:r>
-              <a:rPr lang="en-US" dirty="0"/>
-              <a:t/>
-            </a:r>
-            <a:endParaRPr lang="en-US" dirty="0"/>
+              <a:t>Dùng ba bốn câu hỏi này để mở thảo luận. Câu đầu là tình huống thật: khí xả nóng nhưng thành mixer nguội hơn. Câu hai hỏi cách đo hoặc ước tính nhiệt độ thành. Câu ba đưa vào chu trình lái: xe chạy tải nhẹ, chạy thành phố hoặc dừng lâu hay ở vùng nguy hiểm. Câu bốn về làm sạch bằng nhiệt. Không có đáp án duy nhất; mục tiêu là để người nghe tự gắn các mốc của biểu đồ vào hệ thống của mình.</a:t>
+            </a:r>
           </a:p>
         </p:txBody>
       </p:sp>
@@ -1152,10 +1138,8 @@
           <a:lstStyle/>
           <a:p>
             <a:r>
-              <a:rPr lang="en-US" dirty="0"/>
-              <a:t/>
-            </a:r>
-            <a:endParaRPr lang="en-US" dirty="0"/>
+              <a:t>Slide này tách rõ phần nào là số liệu, phần nào là suy luận. Số liệu: chín điểm đo của hình Source number 3, đọc bằng mắt, sai số khoảng ±2%. Suy luận: tên phản ứng, việc xếp tốt hay xấu, thang rủi ro, các biện pháp, và hai giá trị nội suy ở 160 và 170°C. Đây là thí nghiệm gia nhiệt urea trong phòng thí nghiệm, nên trong xe có thể khác vì tốc độ gia nhiệt, dòng khí, chất xúc tác và dạng giọt phun. Hình chưa rõ tác giả và năm, nên bài chưa đối chiếu từng con số với bài gốc.</a:t>
+            </a:r>
           </a:p>
         </p:txBody>
       </p:sp>
@@ -1240,10 +1224,8 @@
           <a:lstStyle/>
           <a:p>
             <a:r>
-              <a:rPr lang="en-US" dirty="0"/>
-              <a:t/>
-            </a:r>
-            <a:endParaRPr lang="en-US" dirty="0"/>
+              <a:t>Các nguồn của bài. S1 là chính biểu đồ do chủ repo cung cấp. S2 và S3 là hai bài kinh điển về phân hủy nhiệt urea cho SCR. S4 là bài mô hình hóa động học mở (CC BY) tóm tắt bốn vùng nhiệt độ của Schaber. S5 về quá trình đóng cặn urea trong hệ SCR, S6 về thành phần cặn, S7 giải thích AdBlue, S8 là hình từ Wikimedia Commons. Mời người nghe đọc S4 và S5 nếu muốn đi sâu.</a:t>
+            </a:r>
           </a:p>
         </p:txBody>
       </p:sp>
@@ -1328,10 +1310,8 @@
           <a:lstStyle/>
           <a:p>
             <a:r>
-              <a:rPr lang="en-US" dirty="0"/>
-              <a:t/>
-            </a:r>
-            <a:endParaRPr lang="en-US" dirty="0"/>
+              <a:t>AdBlue là nước có 32,5% urea. Kỹ sư hay nghĩ urea là chất khử, nhưng thật ra nó chỉ là kho chứa NH3: nhiệt của ống xả bẻ urea thành NH3, rồi NH3 mới khử NOx trên chất xúc tác. Nước bay hơi trước, urea nóng chảy ở khoảng 133°C và biểu đồ của bài bắt đầu từ đó. Chỗ dễ nhầm: urea không biến hết thành NH3. Nếu nhiệt độ không đủ, một phần thành chất rắn bám lại. Cả bài là câu chuyện của phần rơi vào đường thứ hai đó.</a:t>
+            </a:r>
           </a:p>
         </p:txBody>
       </p:sp>
@@ -1416,10 +1396,8 @@
           <a:lstStyle/>
           <a:p>
             <a:r>
-              <a:rPr lang="en-US" dirty="0"/>
-              <a:t/>
-            </a:r>
-            <a:endParaRPr lang="en-US" dirty="0"/>
+              <a:t>Bốn chất đứng cạnh nhau để người nghe nhận ra mặt chữ. Urea là chất mình muốn có, vì nó cho NH3. Biuret giống bột nhào chưa thành bánh: nó chưa phải cặn cuối nhưng cũng không còn là urea. Cyanuric acid và ammelide là hai chất rắn bền, khó bay hơi, nên là thứ bám lại trong ống. Cấu trúc đơn giản là hai nhóm NH2 quanh một carbon (urea), và các vòng sáu cạnh gồm carbon và nitơ (hai chất cuối). Việc xếp tốt hay xấu là kiến thức của bài, không đọc từ hình.</a:t>
+            </a:r>
           </a:p>
         </p:txBody>
       </p:sp>
@@ -1504,10 +1482,8 @@
           <a:lstStyle/>
           <a:p>
             <a:r>
-              <a:rPr lang="en-US" dirty="0"/>
-              <a:t/>
-            </a:r>
-            <a:endParaRPr lang="en-US" dirty="0"/>
+              <a:t>Đọc biểu đồ theo ba bước. Một: trục ngang là nhiệt độ gia nhiệt, trục dọc là phần trăm khối lượng so với urea ban đầu. Hai: đường navy là total recovery, tổng của bốn chất rắn còn lại; phần thiếu so với 100% đã thành khí chứ không biến mất. Ba: chỉ có chín điểm đo, các đoạn thẳng nối chúng chỉ để mắt dễ theo dõi. Vì vậy hình không cho số đo ở 160 hay 170°C; slide sau sẽ nói rõ chỗ đó. Sai số đọc bằng mắt khoảng ±2%.</a:t>
+            </a:r>
           </a:p>
         </p:txBody>
       </p:sp>
@@ -1592,10 +1568,8 @@
           <a:lstStyle/>
           <a:p>
             <a:r>
-              <a:rPr lang="en-US" dirty="0"/>
-              <a:t/>
-            </a:r>
-            <a:endParaRPr lang="en-US" dirty="0"/>
+              <a:t>Đây là điểm xuất phát: urea nguyên chất, 100% khối lượng, bốn chất còn lại bằng 0. Urea đã nóng chảy thành chất lỏng nhưng gần như chưa phân hủy. Nước trong AdBlue đã bay hơi từ trước nên không có trên đồ thị. Ý nghĩa thực tế: ở mốc này chưa có cặn mới sinh ra, nhưng cũng chưa có nhiều NH3. Chỗ dễ nhầm: 133°C là nhiệt độ của mẫu trong thí nghiệm, không phải nhiệt độ khí xả; trong xe, giọt chạm thành ống thì nhiệt độ thành mới quyết định.</a:t>
+            </a:r>
           </a:p>
         </p:txBody>
       </p:sp>
@@ -1680,10 +1654,8 @@
           <a:lstStyle/>
           <a:p>
             <a:r>
-              <a:rPr lang="en-US" dirty="0"/>
-              <a:t/>
-            </a:r>
-            <a:endParaRPr lang="en-US" dirty="0"/>
+              <a:t>Chủ repo muốn nhìn các mốc 160 và 170°C, nhưng hình không có điểm đo ở đó. Hai hàng ước tính là nội suy tuyến tính giữa 133 và 190°C, nên chỉ là hướng đi: urea giảm dần, biuret tăng dần, tổng chất rắn bắt đầu tụt vì NH3 và HNCO bay đi. Đừng dùng các con số này làm số liệu thiết kế. Muốn số thật ở 160 và 170°C thì phải có thí nghiệm riêng hoặc bài gốc có thêm điểm đo.</a:t>
+            </a:r>
           </a:p>
         </p:txBody>
       </p:sp>
@@ -1768,10 +1740,8 @@
           <a:lstStyle/>
           <a:p>
             <a:r>
-              <a:rPr lang="en-US" dirty="0"/>
-              <a:t/>
-            </a:r>
-            <a:endParaRPr lang="en-US" dirty="0"/>
+              <a:t>Ở 190°C urea đã mất khoảng một nửa. Hai phản ứng chạy song song: urea tách thành NH3 và HNCO, và một phần urea gặp HNCO tạo biuret. Biuret đạt đỉnh khoảng 28%. Cyanuric acid (2,5%) và ammelide (0,5%) mới xuất hiện. Tổng chất rắn còn khoảng 77%, tức khoảng 23% khối lượng đã thành khí. Theo mô tả bốn vùng nhiệt độ của Schaber, từ khoảng 190°C biuret bắt đầu phân hủy, nên đây vừa là đỉnh vừa là điểm quay đầu của biuret.</a:t>
+            </a:r>
           </a:p>
         </p:txBody>
       </p:sp>
@@ -1856,10 +1826,8 @@
           <a:lstStyle/>
           <a:p>
             <a:r>
-              <a:rPr lang="en-US" dirty="0"/>
-              <a:t/>
-            </a:r>
-            <a:endParaRPr lang="en-US" dirty="0"/>
+              <a:t>Đây là vùng chuyển giao. Urea gần cạn, biuret rơi từ 28% xuống 14% rồi còn khoảng 1%. Biuret không biến mất vô cớ: nó bị phân hủy và tạo cyanuric acid cùng ammelide. Ngoài ra ba phân tử HNCO có thể ghép thành một cyanuric acid (kiến thức của bài). Cyanuric acid nhảy từ 2,5% lên 22% rồi 23,5%, trở thành chất chiếm ưu thế. Ý nghĩa thực tế: từ đây cặn không còn là chất mềm, đang đổi tiếp mà là chất rắn bền khó tan.</a:t>
+            </a:r>
           </a:p>
         </p:txBody>
       </p:sp>
@@ -1944,10 +1912,8 @@
           <a:lstStyle/>
           <a:p>
             <a:r>
-              <a:rPr lang="en-US" dirty="0"/>
-              <a:t/>
-            </a:r>
-            <a:endParaRPr lang="en-US" dirty="0"/>
+              <a:t>Từ 275°C trở lên chỉ còn hai chất rắn. Cyanuric acid đạt đỉnh khoảng 24% ở 275°C rồi tụt còn 15% ở 325°C; ammelide đứng yên quanh 5,5%. Theo mô tả của Schaber, vùng 250–360°C là nơi cyanuric acid thăng hoa, nên đường tím đi xuống. Tổng chất rắn còn khoảng 30% rồi 20%: vẫn là lượng đáng kể và đều là chất bền. Đây là vùng thành ống nên tránh nếu muốn không bị đóng cặn.</a:t>
+            </a:r>
           </a:p>
         </p:txBody>
       </p:sp>

</xml_diff>